<commit_message>
Prevent local Kubernetes probe restart loops with CPU and rollout tuning
</commit_message>
<xml_diff>
--- a/docs/submission/Case_Study_Submission-Integrations_and_Microservices_Engineer-Samuel_Mutua_Kimani.pptx
+++ b/docs/submission/Case_Study_Submission-Integrations_and_Microservices_Engineer-Samuel_Mutua_Kimani.pptx
@@ -2,23 +2,23 @@
 <file path=ppt/presentation.xml><?xml version="1.0" encoding="utf-8"?>
 <p:presentation xmlns:p="http://schemas.openxmlformats.org/presentationml/2006/main">
   <p:sldMasterIdLst>
-    <p:sldMasterId xmlns:r="http://schemas.openxmlformats.org/officeDocument/2006/relationships" id="2147483648" r:id="R0105dfefabb8430b"/>
+    <p:sldMasterId xmlns:r="http://schemas.openxmlformats.org/officeDocument/2006/relationships" id="2147483648" r:id="Rc85edb0958a640fe"/>
   </p:sldMasterIdLst>
   <p:notesMasterIdLst>
-    <p:notesMasterId xmlns:r="http://schemas.openxmlformats.org/officeDocument/2006/relationships" r:id="R358d21f276e14e38"/>
+    <p:notesMasterId xmlns:r="http://schemas.openxmlformats.org/officeDocument/2006/relationships" r:id="R25c143cb7d584a4b"/>
   </p:notesMasterIdLst>
   <p:sldIdLst>
-    <p:sldId xmlns:r="http://schemas.openxmlformats.org/officeDocument/2006/relationships" id="256" r:id="R90469dc9f6214331"/>
-    <p:sldId xmlns:r="http://schemas.openxmlformats.org/officeDocument/2006/relationships" id="257" r:id="Ra16ae5da91134449"/>
-    <p:sldId xmlns:r="http://schemas.openxmlformats.org/officeDocument/2006/relationships" id="258" r:id="R2bbe093a63e64270"/>
-    <p:sldId xmlns:r="http://schemas.openxmlformats.org/officeDocument/2006/relationships" id="259" r:id="R79ed08e174ec4c4c"/>
-    <p:sldId xmlns:r="http://schemas.openxmlformats.org/officeDocument/2006/relationships" id="260" r:id="Rb65eb1b62946427e"/>
-    <p:sldId xmlns:r="http://schemas.openxmlformats.org/officeDocument/2006/relationships" id="261" r:id="Rc9341648c65c4bbe"/>
-    <p:sldId xmlns:r="http://schemas.openxmlformats.org/officeDocument/2006/relationships" id="262" r:id="R7ad3e8e6e70544dd"/>
-    <p:sldId xmlns:r="http://schemas.openxmlformats.org/officeDocument/2006/relationships" id="263" r:id="R8d23f71fc38a4065"/>
-    <p:sldId xmlns:r="http://schemas.openxmlformats.org/officeDocument/2006/relationships" id="264" r:id="R4848cbdc8f974569"/>
-    <p:sldId xmlns:r="http://schemas.openxmlformats.org/officeDocument/2006/relationships" id="265" r:id="R18267efc410f4f8e"/>
-    <p:sldId xmlns:r="http://schemas.openxmlformats.org/officeDocument/2006/relationships" id="266" r:id="R4359a0a299e747fc"/>
+    <p:sldId xmlns:r="http://schemas.openxmlformats.org/officeDocument/2006/relationships" id="256" r:id="Rf5df470922ba44ef"/>
+    <p:sldId xmlns:r="http://schemas.openxmlformats.org/officeDocument/2006/relationships" id="257" r:id="R08f1e0e23ea74515"/>
+    <p:sldId xmlns:r="http://schemas.openxmlformats.org/officeDocument/2006/relationships" id="258" r:id="R7b092e58b2e141cd"/>
+    <p:sldId xmlns:r="http://schemas.openxmlformats.org/officeDocument/2006/relationships" id="259" r:id="R75dc9efea52d4671"/>
+    <p:sldId xmlns:r="http://schemas.openxmlformats.org/officeDocument/2006/relationships" id="260" r:id="R67d848b6fd894357"/>
+    <p:sldId xmlns:r="http://schemas.openxmlformats.org/officeDocument/2006/relationships" id="261" r:id="Re94d81208f4d402b"/>
+    <p:sldId xmlns:r="http://schemas.openxmlformats.org/officeDocument/2006/relationships" id="262" r:id="R0963cfc8bed84d9f"/>
+    <p:sldId xmlns:r="http://schemas.openxmlformats.org/officeDocument/2006/relationships" id="263" r:id="Rf5266cc3c56847e1"/>
+    <p:sldId xmlns:r="http://schemas.openxmlformats.org/officeDocument/2006/relationships" id="264" r:id="R2a23320a2dd64de0"/>
+    <p:sldId xmlns:r="http://schemas.openxmlformats.org/officeDocument/2006/relationships" id="265" r:id="R3f298d62cd614dbe"/>
+    <p:sldId xmlns:r="http://schemas.openxmlformats.org/officeDocument/2006/relationships" id="266" r:id="R2638b360e2764a8c"/>
   </p:sldIdLst>
   <p:sldSz cx="12192000" cy="6858000"/>
   <p:notesSz cx="6858000" cy="9144000"/>
@@ -1082,7 +1082,7 @@
           <a:lstStyle xmlns:a="http://schemas.openxmlformats.org/drawingml/2006/main"/>
           <a:p xmlns:a="http://schemas.openxmlformats.org/drawingml/2006/main">
             <a:r>
-              <a:t>Initial deployment checks and cross-replica persistence passed on 8 October 2026. Subsequent Kubernetes checks found both app pods unready after liveness/startup probe timeouts and restarts; MySQL remained ready. See README.md and docs/DEPLOYMENT.md.</a:t>
+              <a:t>The restart loop followed CPU throttling and probe budget overruns. Healthy probe responses took about 8.7 seconds under a five-second timeout. CPU requests increased to 500m and limits to two CPUs. Startup allowance is ten minutes, probe timeout ten seconds, liveness threshold six, and rolling updates replace one pod at a time without surge. New replicas started in 64.443 and 49.013 seconds, reached readiness with zero restarts, and returned identical saved country data. The first cold country reads took about 18 seconds under host load; sustained performance and production availability remain unverified. See README.md and docs/DEPLOYMENT.md.</a:t>
             </a:r>
           </a:p>
         </p:txBody>
@@ -2965,12 +2965,12 @@
   </p:cSld>
   <p:clrMap bg1="lt1" tx1="dk1" bg2="lt2" tx2="dk2" accent1="accent1" accent2="accent2" accent3="accent3" accent4="accent4" accent5="accent5" accent6="accent6" hlink="hlink" folHlink="folHlink"/>
   <p:sldLayoutIdLst>
-    <p:sldLayoutId xmlns:r="http://schemas.openxmlformats.org/officeDocument/2006/relationships" id="2147483649" r:id="R355bb9e86cf9423a"/>
-    <p:sldLayoutId xmlns:r="http://schemas.openxmlformats.org/officeDocument/2006/relationships" id="2147483650" r:id="R8e6f349d8ad04d6c"/>
-    <p:sldLayoutId xmlns:r="http://schemas.openxmlformats.org/officeDocument/2006/relationships" id="2147483651" r:id="Reb0d24f6288b418a"/>
-    <p:sldLayoutId xmlns:r="http://schemas.openxmlformats.org/officeDocument/2006/relationships" id="2147483652" r:id="R81a89b1803484d8c"/>
-    <p:sldLayoutId xmlns:r="http://schemas.openxmlformats.org/officeDocument/2006/relationships" id="2147483653" r:id="R922339f2d5624087"/>
-    <p:sldLayoutId xmlns:r="http://schemas.openxmlformats.org/officeDocument/2006/relationships" id="2147483654" r:id="Rf17f810051014a7a"/>
+    <p:sldLayoutId xmlns:r="http://schemas.openxmlformats.org/officeDocument/2006/relationships" id="2147483649" r:id="R379d22f59bb74a6e"/>
+    <p:sldLayoutId xmlns:r="http://schemas.openxmlformats.org/officeDocument/2006/relationships" id="2147483650" r:id="R9ae8efd54ee24a2d"/>
+    <p:sldLayoutId xmlns:r="http://schemas.openxmlformats.org/officeDocument/2006/relationships" id="2147483651" r:id="R715a8769660b464d"/>
+    <p:sldLayoutId xmlns:r="http://schemas.openxmlformats.org/officeDocument/2006/relationships" id="2147483652" r:id="R4d457ccbdf9b4dc5"/>
+    <p:sldLayoutId xmlns:r="http://schemas.openxmlformats.org/officeDocument/2006/relationships" id="2147483653" r:id="R34166064c1504ad8"/>
+    <p:sldLayoutId xmlns:r="http://schemas.openxmlformats.org/officeDocument/2006/relationships" id="2147483654" r:id="Rcdc6653f2a904520"/>
   </p:sldLayoutIdLst>
   <p:txStyles>
     <p:titleStyle>
@@ -8543,7 +8543,7 @@
                 <a:ea typeface="DejaVu Sans"/>
                 <a:cs typeface="DejaVu Sans"/>
               </a:rPr>
-              <a:t>Startup allows initialization time. Readiness includes database connectivity. Liveness checks application state independently.</a:t>
+              <a:t>Startup allows ten minutes; probes time out after ten seconds. Readiness checks MySQL; six failed liveness checks trigger a restart.</a:t>
             </a:r>
           </a:p>
         </p:txBody>
@@ -9941,7 +9941,7 @@
                 <a:ea typeface="DejaVu Sans"/>
                 <a:cs typeface="DejaVu Sans"/>
               </a:rPr>
-              <a:t>Initial checks passed: two ready app pods, Bound storage and 200 UP health endpoints. Later probe timeouts caused restarts; sustained availability remains unverified.</a:t>
+              <a:t>Recovered after CPU/probe tuning: both replicas ready, health and data checks passed, zero restarts. Startup: 64 and 49 seconds. Production availability unverified.</a:t>
             </a:r>
           </a:p>
         </p:txBody>

</xml_diff>